<commit_message>
Added the project's presentation.
</commit_message>
<xml_diff>
--- a/General Presentation - SpotAid.pptx
+++ b/General Presentation - SpotAid.pptx
@@ -898,7 +898,7 @@
           <a:p>
             <a:fld id="{48A87A34-81AB-432B-8DAE-1953F412C126}" type="datetimeFigureOut">
               <a:rPr lang="en-US" smtClean="0"/>
-              <a:t>1/25/2026</a:t>
+              <a:t>1/26/2026</a:t>
             </a:fld>
             <a:endParaRPr lang="en-US" dirty="0"/>
           </a:p>
@@ -1150,7 +1150,7 @@
             <a:fld id="{48A87A34-81AB-432B-8DAE-1953F412C126}" type="datetimeFigureOut">
               <a:rPr lang="en-US" smtClean="0"/>
               <a:pPr/>
-              <a:t>1/25/2026</a:t>
+              <a:t>1/26/2026</a:t>
             </a:fld>
             <a:endParaRPr lang="en-US" dirty="0"/>
           </a:p>
@@ -1466,7 +1466,7 @@
             <a:fld id="{48A87A34-81AB-432B-8DAE-1953F412C126}" type="datetimeFigureOut">
               <a:rPr lang="en-US" smtClean="0"/>
               <a:pPr/>
-              <a:t>1/25/2026</a:t>
+              <a:t>1/26/2026</a:t>
             </a:fld>
             <a:endParaRPr lang="en-US" dirty="0"/>
           </a:p>
@@ -1809,7 +1809,7 @@
             <a:fld id="{48A87A34-81AB-432B-8DAE-1953F412C126}" type="datetimeFigureOut">
               <a:rPr lang="en-US" smtClean="0"/>
               <a:pPr/>
-              <a:t>1/25/2026</a:t>
+              <a:t>1/26/2026</a:t>
             </a:fld>
             <a:endParaRPr lang="en-US" dirty="0"/>
           </a:p>
@@ -2125,7 +2125,7 @@
             <a:fld id="{48A87A34-81AB-432B-8DAE-1953F412C126}" type="datetimeFigureOut">
               <a:rPr lang="en-US" smtClean="0"/>
               <a:pPr/>
-              <a:t>1/25/2026</a:t>
+              <a:t>1/26/2026</a:t>
             </a:fld>
             <a:endParaRPr lang="en-US" dirty="0"/>
           </a:p>
@@ -2520,7 +2520,7 @@
             <a:fld id="{48A87A34-81AB-432B-8DAE-1953F412C126}" type="datetimeFigureOut">
               <a:rPr lang="en-US" smtClean="0"/>
               <a:pPr/>
-              <a:t>1/25/2026</a:t>
+              <a:t>1/26/2026</a:t>
             </a:fld>
             <a:endParaRPr lang="en-US" dirty="0"/>
           </a:p>
@@ -2691,7 +2691,7 @@
           <a:p>
             <a:fld id="{48A87A34-81AB-432B-8DAE-1953F412C126}" type="datetimeFigureOut">
               <a:rPr lang="en-US" smtClean="0"/>
-              <a:t>1/25/2026</a:t>
+              <a:t>1/26/2026</a:t>
             </a:fld>
             <a:endParaRPr lang="en-US" dirty="0"/>
           </a:p>
@@ -2872,7 +2872,7 @@
             <a:fld id="{48A87A34-81AB-432B-8DAE-1953F412C126}" type="datetimeFigureOut">
               <a:rPr lang="en-US" smtClean="0"/>
               <a:pPr/>
-              <a:t>1/25/2026</a:t>
+              <a:t>1/26/2026</a:t>
             </a:fld>
             <a:endParaRPr lang="en-US" dirty="0"/>
           </a:p>
@@ -3049,7 +3049,7 @@
           <a:p>
             <a:fld id="{48A87A34-81AB-432B-8DAE-1953F412C126}" type="datetimeFigureOut">
               <a:rPr lang="en-US" smtClean="0"/>
-              <a:t>1/25/2026</a:t>
+              <a:t>1/26/2026</a:t>
             </a:fld>
             <a:endParaRPr lang="en-US" dirty="0"/>
           </a:p>
@@ -3296,7 +3296,7 @@
           <a:p>
             <a:fld id="{48A87A34-81AB-432B-8DAE-1953F412C126}" type="datetimeFigureOut">
               <a:rPr lang="en-US" smtClean="0"/>
-              <a:t>1/25/2026</a:t>
+              <a:t>1/26/2026</a:t>
             </a:fld>
             <a:endParaRPr lang="en-US" dirty="0"/>
           </a:p>
@@ -3528,7 +3528,7 @@
           <a:p>
             <a:fld id="{48A87A34-81AB-432B-8DAE-1953F412C126}" type="datetimeFigureOut">
               <a:rPr lang="en-US" smtClean="0"/>
-              <a:t>1/25/2026</a:t>
+              <a:t>1/26/2026</a:t>
             </a:fld>
             <a:endParaRPr lang="en-US" dirty="0"/>
           </a:p>
@@ -3902,7 +3902,7 @@
           <a:p>
             <a:fld id="{48A87A34-81AB-432B-8DAE-1953F412C126}" type="datetimeFigureOut">
               <a:rPr lang="en-US" smtClean="0"/>
-              <a:t>1/25/2026</a:t>
+              <a:t>1/26/2026</a:t>
             </a:fld>
             <a:endParaRPr lang="en-US" dirty="0"/>
           </a:p>
@@ -4025,7 +4025,7 @@
           <a:p>
             <a:fld id="{48A87A34-81AB-432B-8DAE-1953F412C126}" type="datetimeFigureOut">
               <a:rPr lang="en-US" smtClean="0"/>
-              <a:t>1/25/2026</a:t>
+              <a:t>1/26/2026</a:t>
             </a:fld>
             <a:endParaRPr lang="en-US" dirty="0"/>
           </a:p>
@@ -4120,7 +4120,7 @@
           <a:p>
             <a:fld id="{48A87A34-81AB-432B-8DAE-1953F412C126}" type="datetimeFigureOut">
               <a:rPr lang="en-US" smtClean="0"/>
-              <a:t>1/25/2026</a:t>
+              <a:t>1/26/2026</a:t>
             </a:fld>
             <a:endParaRPr lang="en-US" dirty="0"/>
           </a:p>
@@ -4375,7 +4375,7 @@
           <a:p>
             <a:fld id="{48A87A34-81AB-432B-8DAE-1953F412C126}" type="datetimeFigureOut">
               <a:rPr lang="en-US" smtClean="0"/>
-              <a:t>1/25/2026</a:t>
+              <a:t>1/26/2026</a:t>
             </a:fld>
             <a:endParaRPr lang="en-US" dirty="0"/>
           </a:p>
@@ -4638,7 +4638,7 @@
           <a:p>
             <a:fld id="{48A87A34-81AB-432B-8DAE-1953F412C126}" type="datetimeFigureOut">
               <a:rPr lang="en-US" smtClean="0"/>
-              <a:t>1/25/2026</a:t>
+              <a:t>1/26/2026</a:t>
             </a:fld>
             <a:endParaRPr lang="en-US" dirty="0"/>
           </a:p>
@@ -5438,7 +5438,7 @@
             <a:fld id="{48A87A34-81AB-432B-8DAE-1953F412C126}" type="datetimeFigureOut">
               <a:rPr lang="en-US" smtClean="0"/>
               <a:pPr/>
-              <a:t>1/25/2026</a:t>
+              <a:t>1/26/2026</a:t>
             </a:fld>
             <a:endParaRPr lang="en-US" dirty="0"/>
           </a:p>
@@ -6145,7 +6145,7 @@
               <a:rPr lang="en-GB" sz="2000" noProof="0" dirty="0">
                 <a:latin typeface="Aptos SemiBold" panose="020F0502020204030204" pitchFamily="34" charset="0"/>
               </a:rPr>
-              <a:t>The actual system’s distribution of pharmaceutical and </a:t>
+              <a:t>The current distribution system of pharmaceutical and </a:t>
             </a:r>
             <a:r>
               <a:rPr lang="en-GB" sz="2000" noProof="0" dirty="0" err="1">
@@ -6397,7 +6397,7 @@
               <a:rPr lang="en-GB" sz="2000" noProof="0" dirty="0">
                 <a:latin typeface="Aptos SemiBold" panose="020F0502020204030204" pitchFamily="34" charset="0"/>
               </a:rPr>
-              <a:t>The automatic distributors active on the territory, being almost always somewhat close to the pharmacies, have the same issues: the area coverage. </a:t>
+              <a:t>The automatic distributors active on the territory, being almost always somewhat close to the pharmacies, have the same issue: the area coverage. </a:t>
             </a:r>
           </a:p>
           <a:p>
@@ -7881,17 +7881,8 @@
               <a:rPr lang="it-IT" dirty="0">
                 <a:latin typeface="Aptos SemiBold" panose="020B0004020202020204" pitchFamily="34" charset="0"/>
               </a:rPr>
-              <a:t>for the </a:t>
-            </a:r>
-            <a:r>
-              <a:rPr lang="it-IT" dirty="0" err="1">
-                <a:latin typeface="Aptos SemiBold" panose="020B0004020202020204" pitchFamily="34" charset="0"/>
-              </a:rPr>
-              <a:t>citizen</a:t>
-            </a:r>
-            <a:endParaRPr lang="it-IT" dirty="0">
-              <a:latin typeface="Aptos SemiBold" panose="020B0004020202020204" pitchFamily="34" charset="0"/>
-            </a:endParaRPr>
+              <a:t>for the Citizen</a:t>
+            </a:r>
           </a:p>
         </p:txBody>
       </p:sp>
@@ -8345,12 +8336,18 @@
             </a:r>
             <a:r>
               <a:rPr lang="it-IT" dirty="0">
-                <a:latin typeface="Aptos ExtraBold" panose="020F0502020204030204" pitchFamily="34" charset="0"/>
-              </a:rPr>
-              <a:t>for the managers</a:t>
+                <a:latin typeface="Aptos SemiBold" panose="020B0004020202020204" pitchFamily="34" charset="0"/>
+              </a:rPr>
+              <a:t>for the </a:t>
+            </a:r>
+            <a:r>
+              <a:rPr lang="it-IT" dirty="0" err="1">
+                <a:latin typeface="Aptos SemiBold" panose="020B0004020202020204" pitchFamily="34" charset="0"/>
+              </a:rPr>
+              <a:t>Administrators</a:t>
             </a:r>
             <a:endParaRPr lang="it-IT" dirty="0">
-              <a:latin typeface="Bauhaus 93" panose="04030905020B02020C02" pitchFamily="82" charset="0"/>
+              <a:latin typeface="Aptos SemiBold" panose="020B0004020202020204" pitchFamily="34" charset="0"/>
             </a:endParaRPr>
           </a:p>
         </p:txBody>

</xml_diff>